<commit_message>
Make avatars and QR real image placeholders
The avatar circles and QR box were drawn shapes with ［头像］/［微信二维码］
labels, so swapping in a photo meant inserting an image, cropping it to a
circle and positioning it by hand. They are now actual images backed by a
136-byte inline PNG, so in Google Slides it is right-click → Replace image;
the circular crop and the gold ring survive the swap.

The HTML uses the same placeholder as a data URI, so it stays a single file
with no external assets and matches the pptx.

QA: validate.py passes, one A4 page, overflow 0px, no horizontal scroll at
390px or 760px.

Co-Authored-By: Claude Opus 5 <noreply@anthropic.com>
Claude-Session: https://claude.ai/code/session_01UAsxYPqD8rA5dBCrBkqzC1
</commit_message>
<xml_diff>
--- a/topic-table-flyer/flyer-min.pptx
+++ b/topic-table-flyer/flyer-min.pptx
@@ -503,8 +503,8 @@
             <a:r>
               <a:rPr lang="en-US" dirty="0"/>
               <a:t>A4 竖版单页招募单(左右两栏版)。需要发起人自行替换的内容:
-1) 右栏两张头像卡的［头像］与［姓名］—— 换成圆形照片和真名;
-2) 联系卡的［微信二维码］［填入微信号］［填入邮箱］;
+1) 右栏两张头像卡:在灰色圆形上右键 →「替换图片」换成照片(圆形裁切与金环会保留),再改［姓名］;
+2) 联系卡的灰色方块同样右键「替换图片」换成微信二维码,再填［填入微信号］［填入邮箱］;
 3) 品牌名(目前全页未出现,可加在页首小字或页尾)。
 配色:深墨绿 1E3227 / 纸色 F4F2EC / 卡片 E9E7DE / 金 C79A3E。字体只用思源宋体与思源黑体。</a:t>
             </a:r>
@@ -2369,12 +2369,20 @@
           </a:ln>
         </p:spPr>
       </p:sp>
-      <p:sp>
-        <p:nvSpPr>
-          <p:cNvPr id="44" name="Shape 42"/>
-          <p:cNvSpPr/>
-          <p:nvPr/>
-        </p:nvSpPr>
+      <p:pic>
+        <p:nvPicPr>
+          <p:cNvPr id="44" name="Image 0" descr="/home/user/AA222_Final_Project/topic-table-flyer/placeholder.png">    </p:cNvPr>
+          <p:cNvPicPr>
+            <a:picLocks noChangeAspect="1"/>
+          </p:cNvPicPr>
+          <p:nvPr/>
+        </p:nvPicPr>
+        <p:blipFill>
+          <a:blip r:embed="rId1"/>
+          <a:stretch>
+            <a:fillRect/>
+          </a:stretch>
+        </p:blipFill>
         <p:spPr>
           <a:xfrm>
             <a:off x="5047488" y="3136392"/>
@@ -2383,9 +2391,22 @@
           <a:prstGeom prst="ellipse">
             <a:avLst/>
           </a:prstGeom>
-          <a:solidFill>
-            <a:srgbClr val="F4F2EC"/>
-          </a:solidFill>
+        </p:spPr>
+      </p:pic>
+      <p:sp>
+        <p:nvSpPr>
+          <p:cNvPr id="45" name="Shape 42"/>
+          <p:cNvSpPr/>
+          <p:nvPr/>
+        </p:nvSpPr>
+        <p:spPr>
+          <a:xfrm>
+            <a:off x="5047488" y="3136392"/>
+            <a:ext cx="804672" cy="804672"/>
+          </a:xfrm>
+          <a:prstGeom prst="ellipse">
+            <a:avLst/>
+          </a:prstGeom>
           <a:ln w="9525">
             <a:solidFill>
               <a:srgbClr val="C79A3E"/>
@@ -2396,53 +2417,92 @@
       </p:sp>
       <p:sp>
         <p:nvSpPr>
-          <p:cNvPr id="45" name="Text 43"/>
-          <p:cNvSpPr txBox="1"/>
-          <p:nvPr/>
-        </p:nvSpPr>
-        <p:spPr>
-          <a:xfrm>
-            <a:off x="5084064" y="3474720"/>
-            <a:ext cx="731520" cy="146304"/>
-          </a:xfrm>
-          <a:prstGeom prst="rect">
-            <a:avLst/>
-          </a:prstGeom>
-          <a:noFill/>
-          <a:ln/>
-        </p:spPr>
-        <p:txBody>
-          <a:bodyPr wrap="square" lIns="0" tIns="0" rIns="0" bIns="0" rtlCol="0" anchor="t"/>
-          <a:lstStyle/>
-          <a:p>
-            <a:pPr algn="ctr" indent="0" marL="0">
-              <a:buNone/>
-            </a:pPr>
-            <a:r>
-              <a:rPr lang="en-US" sz="650" dirty="0">
-                <a:solidFill>
-                  <a:srgbClr val="4A5F4E"/>
+          <p:cNvPr id="46" name="Text 43"/>
+          <p:cNvSpPr txBox="1"/>
+          <p:nvPr/>
+        </p:nvSpPr>
+        <p:spPr>
+          <a:xfrm>
+            <a:off x="5934456" y="3236976"/>
+            <a:ext cx="932688" cy="219456"/>
+          </a:xfrm>
+          <a:prstGeom prst="rect">
+            <a:avLst/>
+          </a:prstGeom>
+          <a:noFill/>
+          <a:ln/>
+        </p:spPr>
+        <p:txBody>
+          <a:bodyPr wrap="square" lIns="0" tIns="0" rIns="0" bIns="0" rtlCol="0" anchor="t"/>
+          <a:lstStyle/>
+          <a:p>
+            <a:pPr indent="0" marL="0">
+              <a:buNone/>
+            </a:pPr>
+            <a:r>
+              <a:rPr lang="en-US" sz="1200" b="1" dirty="0">
+                <a:solidFill>
+                  <a:srgbClr val="1E3227"/>
+                </a:solidFill>
+                <a:latin typeface="Noto Serif SC" pitchFamily="34" charset="0"/>
+                <a:ea typeface="Noto Serif SC" pitchFamily="34" charset="-122"/>
+                <a:cs typeface="Noto Serif SC" pitchFamily="34" charset="-120"/>
+              </a:rPr>
+              <a:t>［姓名］</a:t>
+            </a:r>
+            <a:endParaRPr lang="en-US" sz="1200" dirty="0"/>
+          </a:p>
+        </p:txBody>
+      </p:sp>
+      <p:sp>
+        <p:nvSpPr>
+          <p:cNvPr id="47" name="Text 44"/>
+          <p:cNvSpPr txBox="1"/>
+          <p:nvPr/>
+        </p:nvSpPr>
+        <p:spPr>
+          <a:xfrm>
+            <a:off x="5934456" y="3493008"/>
+            <a:ext cx="932688" cy="146304"/>
+          </a:xfrm>
+          <a:prstGeom prst="rect">
+            <a:avLst/>
+          </a:prstGeom>
+          <a:noFill/>
+          <a:ln/>
+        </p:spPr>
+        <p:txBody>
+          <a:bodyPr wrap="square" lIns="0" tIns="0" rIns="0" bIns="0" rtlCol="0" anchor="t"/>
+          <a:lstStyle/>
+          <a:p>
+            <a:pPr indent="0" marL="0">
+              <a:buNone/>
+            </a:pPr>
+            <a:r>
+              <a:rPr lang="en-US" sz="740" spc="160" kern="0" dirty="0">
+                <a:solidFill>
+                  <a:srgbClr val="C79A3E"/>
                 </a:solidFill>
                 <a:latin typeface="Noto Sans SC" pitchFamily="34" charset="0"/>
                 <a:ea typeface="Noto Sans SC" pitchFamily="34" charset="-122"/>
                 <a:cs typeface="Noto Sans SC" pitchFamily="34" charset="-120"/>
               </a:rPr>
-              <a:t>［头像］</a:t>
-            </a:r>
-            <a:endParaRPr lang="en-US" sz="650" dirty="0"/>
-          </a:p>
-        </p:txBody>
-      </p:sp>
-      <p:sp>
-        <p:nvSpPr>
-          <p:cNvPr id="46" name="Text 44"/>
-          <p:cNvSpPr txBox="1"/>
-          <p:nvPr/>
-        </p:nvSpPr>
-        <p:spPr>
-          <a:xfrm>
-            <a:off x="5934456" y="3236976"/>
-            <a:ext cx="932688" cy="219456"/>
+              <a:t>哈佛大学</a:t>
+            </a:r>
+            <a:endParaRPr lang="en-US" sz="740" dirty="0"/>
+          </a:p>
+        </p:txBody>
+      </p:sp>
+      <p:sp>
+        <p:nvSpPr>
+          <p:cNvPr id="48" name="Text 45"/>
+          <p:cNvSpPr txBox="1"/>
+          <p:nvPr/>
+        </p:nvSpPr>
+        <p:spPr>
+          <a:xfrm>
+            <a:off x="5934456" y="3675888"/>
+            <a:ext cx="932688" cy="182880"/>
           </a:xfrm>
           <a:prstGeom prst="rect">
             <a:avLst/>
@@ -2458,92 +2518,14 @@
               <a:buNone/>
             </a:pPr>
             <a:r>
-              <a:rPr lang="en-US" sz="1200" b="1" dirty="0">
-                <a:solidFill>
-                  <a:srgbClr val="1E3227"/>
-                </a:solidFill>
-                <a:latin typeface="Noto Serif SC" pitchFamily="34" charset="0"/>
-                <a:ea typeface="Noto Serif SC" pitchFamily="34" charset="-122"/>
-                <a:cs typeface="Noto Serif SC" pitchFamily="34" charset="-120"/>
-              </a:rPr>
-              <a:t>［姓名］</a:t>
-            </a:r>
-            <a:endParaRPr lang="en-US" sz="1200" dirty="0"/>
-          </a:p>
-        </p:txBody>
-      </p:sp>
-      <p:sp>
-        <p:nvSpPr>
-          <p:cNvPr id="47" name="Text 45"/>
-          <p:cNvSpPr txBox="1"/>
-          <p:nvPr/>
-        </p:nvSpPr>
-        <p:spPr>
-          <a:xfrm>
-            <a:off x="5934456" y="3493008"/>
-            <a:ext cx="932688" cy="146304"/>
-          </a:xfrm>
-          <a:prstGeom prst="rect">
-            <a:avLst/>
-          </a:prstGeom>
-          <a:noFill/>
-          <a:ln/>
-        </p:spPr>
-        <p:txBody>
-          <a:bodyPr wrap="square" lIns="0" tIns="0" rIns="0" bIns="0" rtlCol="0" anchor="t"/>
-          <a:lstStyle/>
-          <a:p>
-            <a:pPr indent="0" marL="0">
-              <a:buNone/>
-            </a:pPr>
-            <a:r>
-              <a:rPr lang="en-US" sz="740" spc="160" kern="0" dirty="0">
-                <a:solidFill>
-                  <a:srgbClr val="C79A3E"/>
+              <a:rPr lang="en-US" sz="880" dirty="0">
+                <a:solidFill>
+                  <a:srgbClr val="4A5F4E"/>
                 </a:solidFill>
                 <a:latin typeface="Noto Sans SC" pitchFamily="34" charset="0"/>
                 <a:ea typeface="Noto Sans SC" pitchFamily="34" charset="-122"/>
                 <a:cs typeface="Noto Sans SC" pitchFamily="34" charset="-120"/>
               </a:rPr>
-              <a:t>哈佛大学</a:t>
-            </a:r>
-            <a:endParaRPr lang="en-US" sz="740" dirty="0"/>
-          </a:p>
-        </p:txBody>
-      </p:sp>
-      <p:sp>
-        <p:nvSpPr>
-          <p:cNvPr id="48" name="Text 46"/>
-          <p:cNvSpPr txBox="1"/>
-          <p:nvPr/>
-        </p:nvSpPr>
-        <p:spPr>
-          <a:xfrm>
-            <a:off x="5934456" y="3675888"/>
-            <a:ext cx="932688" cy="182880"/>
-          </a:xfrm>
-          <a:prstGeom prst="rect">
-            <a:avLst/>
-          </a:prstGeom>
-          <a:noFill/>
-          <a:ln/>
-        </p:spPr>
-        <p:txBody>
-          <a:bodyPr wrap="square" lIns="0" tIns="0" rIns="0" bIns="0" rtlCol="0" anchor="t"/>
-          <a:lstStyle/>
-          <a:p>
-            <a:pPr indent="0" marL="0">
-              <a:buNone/>
-            </a:pPr>
-            <a:r>
-              <a:rPr lang="en-US" sz="880" dirty="0">
-                <a:solidFill>
-                  <a:srgbClr val="4A5F4E"/>
-                </a:solidFill>
-                <a:latin typeface="Noto Sans SC" pitchFamily="34" charset="0"/>
-                <a:ea typeface="Noto Sans SC" pitchFamily="34" charset="-122"/>
-                <a:cs typeface="Noto Sans SC" pitchFamily="34" charset="-120"/>
-              </a:rPr>
               <a:t>产品与工程</a:t>
             </a:r>
             <a:endParaRPr lang="en-US" sz="880" dirty="0"/>
@@ -2552,7 +2534,7 @@
       </p:sp>
       <p:sp>
         <p:nvSpPr>
-          <p:cNvPr id="49" name="Shape 47"/>
+          <p:cNvPr id="49" name="Shape 46"/>
           <p:cNvSpPr/>
           <p:nvPr/>
         </p:nvSpPr>
@@ -2575,12 +2557,20 @@
           </a:ln>
         </p:spPr>
       </p:sp>
-      <p:sp>
-        <p:nvSpPr>
-          <p:cNvPr id="50" name="Shape 48"/>
-          <p:cNvSpPr/>
-          <p:nvPr/>
-        </p:nvSpPr>
+      <p:pic>
+        <p:nvPicPr>
+          <p:cNvPr id="50" name="Image 1" descr="/home/user/AA222_Final_Project/topic-table-flyer/placeholder.png">    </p:cNvPr>
+          <p:cNvPicPr>
+            <a:picLocks noChangeAspect="1"/>
+          </p:cNvPicPr>
+          <p:nvPr/>
+        </p:nvPicPr>
+        <p:blipFill>
+          <a:blip r:embed="rId2"/>
+          <a:stretch>
+            <a:fillRect/>
+          </a:stretch>
+        </p:blipFill>
         <p:spPr>
           <a:xfrm>
             <a:off x="5047488" y="4471416"/>
@@ -2589,9 +2579,22 @@
           <a:prstGeom prst="ellipse">
             <a:avLst/>
           </a:prstGeom>
-          <a:solidFill>
-            <a:srgbClr val="F4F2EC"/>
-          </a:solidFill>
+        </p:spPr>
+      </p:pic>
+      <p:sp>
+        <p:nvSpPr>
+          <p:cNvPr id="51" name="Shape 47"/>
+          <p:cNvSpPr/>
+          <p:nvPr/>
+        </p:nvSpPr>
+        <p:spPr>
+          <a:xfrm>
+            <a:off x="5047488" y="4471416"/>
+            <a:ext cx="804672" cy="804672"/>
+          </a:xfrm>
+          <a:prstGeom prst="ellipse">
+            <a:avLst/>
+          </a:prstGeom>
           <a:ln w="9525">
             <a:solidFill>
               <a:srgbClr val="C79A3E"/>
@@ -2602,53 +2605,92 @@
       </p:sp>
       <p:sp>
         <p:nvSpPr>
-          <p:cNvPr id="51" name="Text 49"/>
-          <p:cNvSpPr txBox="1"/>
-          <p:nvPr/>
-        </p:nvSpPr>
-        <p:spPr>
-          <a:xfrm>
-            <a:off x="5084064" y="4809744"/>
-            <a:ext cx="731520" cy="146304"/>
-          </a:xfrm>
-          <a:prstGeom prst="rect">
-            <a:avLst/>
-          </a:prstGeom>
-          <a:noFill/>
-          <a:ln/>
-        </p:spPr>
-        <p:txBody>
-          <a:bodyPr wrap="square" lIns="0" tIns="0" rIns="0" bIns="0" rtlCol="0" anchor="t"/>
-          <a:lstStyle/>
-          <a:p>
-            <a:pPr algn="ctr" indent="0" marL="0">
-              <a:buNone/>
-            </a:pPr>
-            <a:r>
-              <a:rPr lang="en-US" sz="650" dirty="0">
-                <a:solidFill>
-                  <a:srgbClr val="4A5F4E"/>
+          <p:cNvPr id="52" name="Text 48"/>
+          <p:cNvSpPr txBox="1"/>
+          <p:nvPr/>
+        </p:nvSpPr>
+        <p:spPr>
+          <a:xfrm>
+            <a:off x="5934456" y="4572000"/>
+            <a:ext cx="932688" cy="219456"/>
+          </a:xfrm>
+          <a:prstGeom prst="rect">
+            <a:avLst/>
+          </a:prstGeom>
+          <a:noFill/>
+          <a:ln/>
+        </p:spPr>
+        <p:txBody>
+          <a:bodyPr wrap="square" lIns="0" tIns="0" rIns="0" bIns="0" rtlCol="0" anchor="t"/>
+          <a:lstStyle/>
+          <a:p>
+            <a:pPr indent="0" marL="0">
+              <a:buNone/>
+            </a:pPr>
+            <a:r>
+              <a:rPr lang="en-US" sz="1200" b="1" dirty="0">
+                <a:solidFill>
+                  <a:srgbClr val="1E3227"/>
+                </a:solidFill>
+                <a:latin typeface="Noto Serif SC" pitchFamily="34" charset="0"/>
+                <a:ea typeface="Noto Serif SC" pitchFamily="34" charset="-122"/>
+                <a:cs typeface="Noto Serif SC" pitchFamily="34" charset="-120"/>
+              </a:rPr>
+              <a:t>［姓名］</a:t>
+            </a:r>
+            <a:endParaRPr lang="en-US" sz="1200" dirty="0"/>
+          </a:p>
+        </p:txBody>
+      </p:sp>
+      <p:sp>
+        <p:nvSpPr>
+          <p:cNvPr id="53" name="Text 49"/>
+          <p:cNvSpPr txBox="1"/>
+          <p:nvPr/>
+        </p:nvSpPr>
+        <p:spPr>
+          <a:xfrm>
+            <a:off x="5934456" y="4828032"/>
+            <a:ext cx="932688" cy="146304"/>
+          </a:xfrm>
+          <a:prstGeom prst="rect">
+            <a:avLst/>
+          </a:prstGeom>
+          <a:noFill/>
+          <a:ln/>
+        </p:spPr>
+        <p:txBody>
+          <a:bodyPr wrap="square" lIns="0" tIns="0" rIns="0" bIns="0" rtlCol="0" anchor="t"/>
+          <a:lstStyle/>
+          <a:p>
+            <a:pPr indent="0" marL="0">
+              <a:buNone/>
+            </a:pPr>
+            <a:r>
+              <a:rPr lang="en-US" sz="740" spc="160" kern="0" dirty="0">
+                <a:solidFill>
+                  <a:srgbClr val="C79A3E"/>
                 </a:solidFill>
                 <a:latin typeface="Noto Sans SC" pitchFamily="34" charset="0"/>
                 <a:ea typeface="Noto Sans SC" pitchFamily="34" charset="-122"/>
                 <a:cs typeface="Noto Sans SC" pitchFamily="34" charset="-120"/>
               </a:rPr>
-              <a:t>［头像］</a:t>
-            </a:r>
-            <a:endParaRPr lang="en-US" sz="650" dirty="0"/>
-          </a:p>
-        </p:txBody>
-      </p:sp>
-      <p:sp>
-        <p:nvSpPr>
-          <p:cNvPr id="52" name="Text 50"/>
-          <p:cNvSpPr txBox="1"/>
-          <p:nvPr/>
-        </p:nvSpPr>
-        <p:spPr>
-          <a:xfrm>
-            <a:off x="5934456" y="4572000"/>
-            <a:ext cx="932688" cy="219456"/>
+              <a:t>斯坦福大学</a:t>
+            </a:r>
+            <a:endParaRPr lang="en-US" sz="740" dirty="0"/>
+          </a:p>
+        </p:txBody>
+      </p:sp>
+      <p:sp>
+        <p:nvSpPr>
+          <p:cNvPr id="54" name="Text 50"/>
+          <p:cNvSpPr txBox="1"/>
+          <p:nvPr/>
+        </p:nvSpPr>
+        <p:spPr>
+          <a:xfrm>
+            <a:off x="5934456" y="5010912"/>
+            <a:ext cx="932688" cy="182880"/>
           </a:xfrm>
           <a:prstGeom prst="rect">
             <a:avLst/>
@@ -2664,92 +2706,14 @@
               <a:buNone/>
             </a:pPr>
             <a:r>
-              <a:rPr lang="en-US" sz="1200" b="1" dirty="0">
-                <a:solidFill>
-                  <a:srgbClr val="1E3227"/>
-                </a:solidFill>
-                <a:latin typeface="Noto Serif SC" pitchFamily="34" charset="0"/>
-                <a:ea typeface="Noto Serif SC" pitchFamily="34" charset="-122"/>
-                <a:cs typeface="Noto Serif SC" pitchFamily="34" charset="-120"/>
-              </a:rPr>
-              <a:t>［姓名］</a:t>
-            </a:r>
-            <a:endParaRPr lang="en-US" sz="1200" dirty="0"/>
-          </a:p>
-        </p:txBody>
-      </p:sp>
-      <p:sp>
-        <p:nvSpPr>
-          <p:cNvPr id="53" name="Text 51"/>
-          <p:cNvSpPr txBox="1"/>
-          <p:nvPr/>
-        </p:nvSpPr>
-        <p:spPr>
-          <a:xfrm>
-            <a:off x="5934456" y="4828032"/>
-            <a:ext cx="932688" cy="146304"/>
-          </a:xfrm>
-          <a:prstGeom prst="rect">
-            <a:avLst/>
-          </a:prstGeom>
-          <a:noFill/>
-          <a:ln/>
-        </p:spPr>
-        <p:txBody>
-          <a:bodyPr wrap="square" lIns="0" tIns="0" rIns="0" bIns="0" rtlCol="0" anchor="t"/>
-          <a:lstStyle/>
-          <a:p>
-            <a:pPr indent="0" marL="0">
-              <a:buNone/>
-            </a:pPr>
-            <a:r>
-              <a:rPr lang="en-US" sz="740" spc="160" kern="0" dirty="0">
-                <a:solidFill>
-                  <a:srgbClr val="C79A3E"/>
+              <a:rPr lang="en-US" sz="880" dirty="0">
+                <a:solidFill>
+                  <a:srgbClr val="4A5F4E"/>
                 </a:solidFill>
                 <a:latin typeface="Noto Sans SC" pitchFamily="34" charset="0"/>
                 <a:ea typeface="Noto Sans SC" pitchFamily="34" charset="-122"/>
                 <a:cs typeface="Noto Sans SC" pitchFamily="34" charset="-120"/>
               </a:rPr>
-              <a:t>斯坦福大学</a:t>
-            </a:r>
-            <a:endParaRPr lang="en-US" sz="740" dirty="0"/>
-          </a:p>
-        </p:txBody>
-      </p:sp>
-      <p:sp>
-        <p:nvSpPr>
-          <p:cNvPr id="54" name="Text 52"/>
-          <p:cNvSpPr txBox="1"/>
-          <p:nvPr/>
-        </p:nvSpPr>
-        <p:spPr>
-          <a:xfrm>
-            <a:off x="5934456" y="5010912"/>
-            <a:ext cx="932688" cy="182880"/>
-          </a:xfrm>
-          <a:prstGeom prst="rect">
-            <a:avLst/>
-          </a:prstGeom>
-          <a:noFill/>
-          <a:ln/>
-        </p:spPr>
-        <p:txBody>
-          <a:bodyPr wrap="square" lIns="0" tIns="0" rIns="0" bIns="0" rtlCol="0" anchor="t"/>
-          <a:lstStyle/>
-          <a:p>
-            <a:pPr indent="0" marL="0">
-              <a:buNone/>
-            </a:pPr>
-            <a:r>
-              <a:rPr lang="en-US" sz="880" dirty="0">
-                <a:solidFill>
-                  <a:srgbClr val="4A5F4E"/>
-                </a:solidFill>
-                <a:latin typeface="Noto Sans SC" pitchFamily="34" charset="0"/>
-                <a:ea typeface="Noto Sans SC" pitchFamily="34" charset="-122"/>
-                <a:cs typeface="Noto Sans SC" pitchFamily="34" charset="-120"/>
-              </a:rPr>
               <a:t>品牌与内容</a:t>
             </a:r>
             <a:endParaRPr lang="en-US" sz="880" dirty="0"/>
@@ -2758,7 +2722,7 @@
       </p:sp>
       <p:sp>
         <p:nvSpPr>
-          <p:cNvPr id="55" name="Text 53"/>
+          <p:cNvPr id="55" name="Text 51"/>
           <p:cNvSpPr txBox="1"/>
           <p:nvPr/>
         </p:nvSpPr>
@@ -2800,7 +2764,7 @@
       </p:sp>
       <p:sp>
         <p:nvSpPr>
-          <p:cNvPr id="56" name="Shape 54"/>
+          <p:cNvPr id="56" name="Shape 52"/>
           <p:cNvSpPr/>
           <p:nvPr/>
         </p:nvSpPr>
@@ -2825,7 +2789,7 @@
       </p:sp>
       <p:sp>
         <p:nvSpPr>
-          <p:cNvPr id="57" name="Text 55"/>
+          <p:cNvPr id="57" name="Text 53"/>
           <p:cNvSpPr txBox="1"/>
           <p:nvPr/>
         </p:nvSpPr>
@@ -2862,12 +2826,20 @@
           </a:p>
         </p:txBody>
       </p:sp>
-      <p:sp>
-        <p:nvSpPr>
-          <p:cNvPr id="58" name="Shape 56"/>
-          <p:cNvSpPr/>
-          <p:nvPr/>
-        </p:nvSpPr>
+      <p:pic>
+        <p:nvPicPr>
+          <p:cNvPr id="58" name="Image 2" descr="/home/user/AA222_Final_Project/topic-table-flyer/placeholder.png">    </p:cNvPr>
+          <p:cNvPicPr>
+            <a:picLocks noChangeAspect="1"/>
+          </p:cNvPicPr>
+          <p:nvPr/>
+        </p:nvPicPr>
+        <p:blipFill>
+          <a:blip r:embed="rId3"/>
+          <a:stretch>
+            <a:fillRect/>
+          </a:stretch>
+        </p:blipFill>
         <p:spPr>
           <a:xfrm>
             <a:off x="5472684" y="8613648"/>
@@ -2876,9 +2848,22 @@
           <a:prstGeom prst="rect">
             <a:avLst/>
           </a:prstGeom>
-          <a:solidFill>
-            <a:srgbClr val="F4F2EC"/>
-          </a:solidFill>
+        </p:spPr>
+      </p:pic>
+      <p:sp>
+        <p:nvSpPr>
+          <p:cNvPr id="59" name="Shape 54"/>
+          <p:cNvSpPr/>
+          <p:nvPr/>
+        </p:nvSpPr>
+        <p:spPr>
+          <a:xfrm>
+            <a:off x="5472684" y="8613648"/>
+            <a:ext cx="960120" cy="960120"/>
+          </a:xfrm>
+          <a:prstGeom prst="rect">
+            <a:avLst/>
+          </a:prstGeom>
           <a:ln w="9525">
             <a:solidFill>
               <a:srgbClr val="C79A3E"/>
@@ -2889,53 +2874,69 @@
       </p:sp>
       <p:sp>
         <p:nvSpPr>
-          <p:cNvPr id="59" name="Text 57"/>
-          <p:cNvSpPr txBox="1"/>
-          <p:nvPr/>
-        </p:nvSpPr>
-        <p:spPr>
-          <a:xfrm>
-            <a:off x="5472684" y="8988552"/>
-            <a:ext cx="960120" cy="310896"/>
-          </a:xfrm>
-          <a:prstGeom prst="rect">
-            <a:avLst/>
-          </a:prstGeom>
-          <a:noFill/>
-          <a:ln/>
-        </p:spPr>
-        <p:txBody>
-          <a:bodyPr wrap="square" lIns="0" tIns="0" rIns="0" bIns="0" rtlCol="0" anchor="t"/>
-          <a:lstStyle/>
-          <a:p>
-            <a:pPr algn="ctr" indent="0" marL="0">
-              <a:lnSpc>
-                <a:spcPct val="120000"/>
-              </a:lnSpc>
-              <a:buNone/>
-            </a:pPr>
-            <a:r>
-              <a:rPr lang="en-US" sz="650" dirty="0">
-                <a:solidFill>
-                  <a:srgbClr val="4A5F4E"/>
+          <p:cNvPr id="60" name="Text 55"/>
+          <p:cNvSpPr txBox="1"/>
+          <p:nvPr/>
+        </p:nvSpPr>
+        <p:spPr>
+          <a:xfrm>
+            <a:off x="5065776" y="9646920"/>
+            <a:ext cx="384048" cy="164592"/>
+          </a:xfrm>
+          <a:prstGeom prst="rect">
+            <a:avLst/>
+          </a:prstGeom>
+          <a:noFill/>
+          <a:ln/>
+        </p:spPr>
+        <p:txBody>
+          <a:bodyPr wrap="square" lIns="0" tIns="0" rIns="0" bIns="0" rtlCol="0" anchor="t"/>
+          <a:lstStyle/>
+          <a:p>
+            <a:pPr indent="0" marL="0">
+              <a:buNone/>
+            </a:pPr>
+            <a:r>
+              <a:rPr lang="en-US" sz="880" dirty="0">
+                <a:solidFill>
+                  <a:srgbClr val="1E3227"/>
                 </a:solidFill>
                 <a:latin typeface="Noto Sans SC" pitchFamily="34" charset="0"/>
                 <a:ea typeface="Noto Sans SC" pitchFamily="34" charset="-122"/>
                 <a:cs typeface="Noto Sans SC" pitchFamily="34" charset="-120"/>
               </a:rPr>
-              <a:t>［微信</a:t>
-            </a:r>
-            <a:endParaRPr lang="en-US" sz="650" dirty="0"/>
-          </a:p>
-          <a:p>
-            <a:pPr algn="ctr" indent="0" marL="0">
-              <a:lnSpc>
-                <a:spcPct val="120000"/>
-              </a:lnSpc>
-              <a:buNone/>
-            </a:pPr>
-            <a:r>
-              <a:rPr lang="en-US" sz="650" dirty="0">
+              <a:t>微信</a:t>
+            </a:r>
+            <a:endParaRPr lang="en-US" sz="880" dirty="0"/>
+          </a:p>
+        </p:txBody>
+      </p:sp>
+      <p:sp>
+        <p:nvSpPr>
+          <p:cNvPr id="61" name="Text 56"/>
+          <p:cNvSpPr txBox="1"/>
+          <p:nvPr/>
+        </p:nvSpPr>
+        <p:spPr>
+          <a:xfrm>
+            <a:off x="5495544" y="9646920"/>
+            <a:ext cx="1371600" cy="164592"/>
+          </a:xfrm>
+          <a:prstGeom prst="rect">
+            <a:avLst/>
+          </a:prstGeom>
+          <a:noFill/>
+          <a:ln/>
+        </p:spPr>
+        <p:txBody>
+          <a:bodyPr wrap="square" lIns="0" tIns="0" rIns="0" bIns="0" rtlCol="0" anchor="t"/>
+          <a:lstStyle/>
+          <a:p>
+            <a:pPr indent="0" marL="0">
+              <a:buNone/>
+            </a:pPr>
+            <a:r>
+              <a:rPr lang="en-US" sz="880" dirty="0">
                 <a:solidFill>
                   <a:srgbClr val="4A5F4E"/>
                 </a:solidFill>
@@ -2943,21 +2944,21 @@
                 <a:ea typeface="Noto Sans SC" pitchFamily="34" charset="-122"/>
                 <a:cs typeface="Noto Sans SC" pitchFamily="34" charset="-120"/>
               </a:rPr>
-              <a:t>二维码］</a:t>
-            </a:r>
-            <a:endParaRPr lang="en-US" sz="650" dirty="0"/>
-          </a:p>
-        </p:txBody>
-      </p:sp>
-      <p:sp>
-        <p:nvSpPr>
-          <p:cNvPr id="60" name="Text 58"/>
-          <p:cNvSpPr txBox="1"/>
-          <p:nvPr/>
-        </p:nvSpPr>
-        <p:spPr>
-          <a:xfrm>
-            <a:off x="5065776" y="9646920"/>
+              <a:t>［填入微信号］</a:t>
+            </a:r>
+            <a:endParaRPr lang="en-US" sz="880" dirty="0"/>
+          </a:p>
+        </p:txBody>
+      </p:sp>
+      <p:sp>
+        <p:nvSpPr>
+          <p:cNvPr id="62" name="Text 57"/>
+          <p:cNvSpPr txBox="1"/>
+          <p:nvPr/>
+        </p:nvSpPr>
+        <p:spPr>
+          <a:xfrm>
+            <a:off x="5065776" y="9820656"/>
             <a:ext cx="384048" cy="164592"/>
           </a:xfrm>
           <a:prstGeom prst="rect">
@@ -2982,7 +2983,7 @@
                 <a:ea typeface="Noto Sans SC" pitchFamily="34" charset="-122"/>
                 <a:cs typeface="Noto Sans SC" pitchFamily="34" charset="-120"/>
               </a:rPr>
-              <a:t>微信</a:t>
+              <a:t>邮箱</a:t>
             </a:r>
             <a:endParaRPr lang="en-US" sz="880" dirty="0"/>
           </a:p>
@@ -2990,13 +2991,13 @@
       </p:sp>
       <p:sp>
         <p:nvSpPr>
-          <p:cNvPr id="61" name="Text 59"/>
-          <p:cNvSpPr txBox="1"/>
-          <p:nvPr/>
-        </p:nvSpPr>
-        <p:spPr>
-          <a:xfrm>
-            <a:off x="5495544" y="9646920"/>
+          <p:cNvPr id="63" name="Text 58"/>
+          <p:cNvSpPr txBox="1"/>
+          <p:nvPr/>
+        </p:nvSpPr>
+        <p:spPr>
+          <a:xfrm>
+            <a:off x="5495544" y="9820656"/>
             <a:ext cx="1371600" cy="164592"/>
           </a:xfrm>
           <a:prstGeom prst="rect">
@@ -3021,7 +3022,7 @@
                 <a:ea typeface="Noto Sans SC" pitchFamily="34" charset="-122"/>
                 <a:cs typeface="Noto Sans SC" pitchFamily="34" charset="-120"/>
               </a:rPr>
-              <a:t>［填入微信号］</a:t>
+              <a:t>［填入邮箱］</a:t>
             </a:r>
             <a:endParaRPr lang="en-US" sz="880" dirty="0"/>
           </a:p>
@@ -3029,85 +3030,7 @@
       </p:sp>
       <p:sp>
         <p:nvSpPr>
-          <p:cNvPr id="62" name="Text 60"/>
-          <p:cNvSpPr txBox="1"/>
-          <p:nvPr/>
-        </p:nvSpPr>
-        <p:spPr>
-          <a:xfrm>
-            <a:off x="5065776" y="9820656"/>
-            <a:ext cx="384048" cy="164592"/>
-          </a:xfrm>
-          <a:prstGeom prst="rect">
-            <a:avLst/>
-          </a:prstGeom>
-          <a:noFill/>
-          <a:ln/>
-        </p:spPr>
-        <p:txBody>
-          <a:bodyPr wrap="square" lIns="0" tIns="0" rIns="0" bIns="0" rtlCol="0" anchor="t"/>
-          <a:lstStyle/>
-          <a:p>
-            <a:pPr indent="0" marL="0">
-              <a:buNone/>
-            </a:pPr>
-            <a:r>
-              <a:rPr lang="en-US" sz="880" dirty="0">
-                <a:solidFill>
-                  <a:srgbClr val="1E3227"/>
-                </a:solidFill>
-                <a:latin typeface="Noto Sans SC" pitchFamily="34" charset="0"/>
-                <a:ea typeface="Noto Sans SC" pitchFamily="34" charset="-122"/>
-                <a:cs typeface="Noto Sans SC" pitchFamily="34" charset="-120"/>
-              </a:rPr>
-              <a:t>邮箱</a:t>
-            </a:r>
-            <a:endParaRPr lang="en-US" sz="880" dirty="0"/>
-          </a:p>
-        </p:txBody>
-      </p:sp>
-      <p:sp>
-        <p:nvSpPr>
-          <p:cNvPr id="63" name="Text 61"/>
-          <p:cNvSpPr txBox="1"/>
-          <p:nvPr/>
-        </p:nvSpPr>
-        <p:spPr>
-          <a:xfrm>
-            <a:off x="5495544" y="9820656"/>
-            <a:ext cx="1371600" cy="164592"/>
-          </a:xfrm>
-          <a:prstGeom prst="rect">
-            <a:avLst/>
-          </a:prstGeom>
-          <a:noFill/>
-          <a:ln/>
-        </p:spPr>
-        <p:txBody>
-          <a:bodyPr wrap="square" lIns="0" tIns="0" rIns="0" bIns="0" rtlCol="0" anchor="t"/>
-          <a:lstStyle/>
-          <a:p>
-            <a:pPr indent="0" marL="0">
-              <a:buNone/>
-            </a:pPr>
-            <a:r>
-              <a:rPr lang="en-US" sz="880" dirty="0">
-                <a:solidFill>
-                  <a:srgbClr val="4A5F4E"/>
-                </a:solidFill>
-                <a:latin typeface="Noto Sans SC" pitchFamily="34" charset="0"/>
-                <a:ea typeface="Noto Sans SC" pitchFamily="34" charset="-122"/>
-                <a:cs typeface="Noto Sans SC" pitchFamily="34" charset="-120"/>
-              </a:rPr>
-              <a:t>［填入邮箱］</a:t>
-            </a:r>
-            <a:endParaRPr lang="en-US" sz="880" dirty="0"/>
-          </a:p>
-        </p:txBody>
-      </p:sp>
-      <p:sp>
-        <p:nvSpPr>
-          <p:cNvPr id="64" name="Shape 62"/>
+          <p:cNvPr id="64" name="Shape 59"/>
           <p:cNvSpPr/>
           <p:nvPr/>
         </p:nvSpPr>
@@ -3132,7 +3055,7 @@
       </p:sp>
       <p:sp>
         <p:nvSpPr>
-          <p:cNvPr id="65" name="Text 63"/>
+          <p:cNvPr id="65" name="Text 60"/>
           <p:cNvSpPr txBox="1"/>
           <p:nvPr/>
         </p:nvSpPr>
@@ -3171,7 +3094,7 @@
       </p:sp>
       <p:sp>
         <p:nvSpPr>
-          <p:cNvPr id="66" name="Text 64"/>
+          <p:cNvPr id="66" name="Text 61"/>
           <p:cNvSpPr txBox="1"/>
           <p:nvPr/>
         </p:nvSpPr>

</xml_diff>